<commit_message>
Fix road names around the bride's home
Per the user's Amap screenshots:
- The diagonal from 腰周家 to 红旗大市场 is 新华街, not G102
- The north-south road west of the city is 德环路; 德农环路 is only the
  eastward part from the 德环路/新华街 junction
- Draw the real G102 to the southeast, where 德农环路 ends at it
- Drop the G102 shield from the village road to 腰周家 (name unknown)

Co-Authored-By: Claude Opus 5.5 <noreply@anthropic.com>
Claude-Session: https://claude.ai/code/session_014xWo2Dszvks45w7evtNpHL
</commit_message>
<xml_diff>
--- a/wedding-route/wedding_route_map.pptx
+++ b/wedding-route/wedding_route_map.pptx
@@ -3233,13 +3233,57 @@
       </p:sp>
       <p:sp>
         <p:nvSpPr>
-          <p:cNvPr id="5" name="德农环路"/>
+          <p:cNvPr id="5" name="德环路"/>
           <p:cNvSpPr txBox="1"/>
           <p:nvPr/>
         </p:nvSpPr>
         <p:spPr>
           <a:xfrm rot="4781709">
-            <a:off x="10172604" y="9034031"/>
+            <a:off x="10298791" y="9034031"/>
+            <a:ext cx="830275" cy="291876"/>
+          </a:xfrm>
+          <a:prstGeom prst="rect">
+            <a:avLst/>
+          </a:prstGeom>
+          <a:noFill/>
+        </p:spPr>
+        <p:txBody>
+          <a:bodyPr wrap="none" anchor="t" lIns="0" rIns="0" tIns="0" bIns="0">
+            <a:noAutofit/>
+          </a:bodyPr>
+          <a:lstStyle/>
+          <a:p>
+            <a:pPr algn="ctr"/>
+            <a:r>
+              <a:rPr lang="zh-CN" sz="1728" b="0">
+                <a:solidFill>
+                  <a:srgbClr val="5B5B5B"/>
+                </a:solidFill>
+                <a:effectLst>
+                  <a:glow rad="27432">
+                    <a:srgbClr val="FFF3F7">
+                      <a:alpha val="90000"/>
+                    </a:srgbClr>
+                  </a:glow>
+                </a:effectLst>
+                <a:latin typeface="微软雅黑"/>
+                <a:ea typeface="微软雅黑"/>
+                <a:cs typeface="微软雅黑"/>
+              </a:rPr>
+              <a:t>德环路</a:t>
+            </a:r>
+          </a:p>
+        </p:txBody>
+      </p:sp>
+      <p:sp>
+        <p:nvSpPr>
+          <p:cNvPr id="6" name="德农环路"/>
+          <p:cNvSpPr txBox="1"/>
+          <p:nvPr/>
+        </p:nvSpPr>
+        <p:spPr>
+          <a:xfrm rot="810994">
+            <a:off x="12263622" y="9869318"/>
             <a:ext cx="1082649" cy="291876"/>
           </a:xfrm>
           <a:prstGeom prst="rect">
@@ -3277,50 +3321,6 @@
       </p:sp>
       <p:sp>
         <p:nvSpPr>
-          <p:cNvPr id="6" name="德农环路"/>
-          <p:cNvSpPr txBox="1"/>
-          <p:nvPr/>
-        </p:nvSpPr>
-        <p:spPr>
-          <a:xfrm rot="810994">
-            <a:off x="12263622" y="9869318"/>
-            <a:ext cx="1082649" cy="291876"/>
-          </a:xfrm>
-          <a:prstGeom prst="rect">
-            <a:avLst/>
-          </a:prstGeom>
-          <a:noFill/>
-        </p:spPr>
-        <p:txBody>
-          <a:bodyPr wrap="none" anchor="t" lIns="0" rIns="0" tIns="0" bIns="0">
-            <a:noAutofit/>
-          </a:bodyPr>
-          <a:lstStyle/>
-          <a:p>
-            <a:pPr algn="ctr"/>
-            <a:r>
-              <a:rPr lang="zh-CN" sz="1728" b="0">
-                <a:solidFill>
-                  <a:srgbClr val="5B5B5B"/>
-                </a:solidFill>
-                <a:effectLst>
-                  <a:glow rad="27432">
-                    <a:srgbClr val="FFF3F7">
-                      <a:alpha val="90000"/>
-                    </a:srgbClr>
-                  </a:glow>
-                </a:effectLst>
-                <a:latin typeface="微软雅黑"/>
-                <a:ea typeface="微软雅黑"/>
-                <a:cs typeface="微软雅黑"/>
-              </a:rPr>
-              <a:t>德农环路</a:t>
-            </a:r>
-          </a:p>
-        </p:txBody>
-      </p:sp>
-      <p:sp>
-        <p:nvSpPr>
           <p:cNvPr id="7" name="京哈高速"/>
           <p:cNvSpPr txBox="1"/>
           <p:nvPr/>
@@ -3453,14 +3453,14 @@
       </p:sp>
       <p:sp>
         <p:nvSpPr>
-          <p:cNvPr id="10" name="G102国道"/>
+          <p:cNvPr id="10" name="新华街"/>
           <p:cNvSpPr txBox="1"/>
           <p:nvPr/>
         </p:nvSpPr>
         <p:spPr>
           <a:xfrm rot="18842470">
-            <a:off x="12076860" y="9144409"/>
-            <a:ext cx="1276136" cy="316199"/>
+            <a:off x="12268244" y="9144409"/>
+            <a:ext cx="893368" cy="316199"/>
           </a:xfrm>
           <a:prstGeom prst="rect">
             <a:avLst/>
@@ -3476,6 +3476,50 @@
             <a:pPr algn="ctr"/>
             <a:r>
               <a:rPr lang="zh-CN" sz="1872" b="0">
+                <a:solidFill>
+                  <a:srgbClr val="5B5B5B"/>
+                </a:solidFill>
+                <a:effectLst>
+                  <a:glow rad="27432">
+                    <a:srgbClr val="FFF3F7">
+                      <a:alpha val="90000"/>
+                    </a:srgbClr>
+                  </a:glow>
+                </a:effectLst>
+                <a:latin typeface="微软雅黑"/>
+                <a:ea typeface="微软雅黑"/>
+                <a:cs typeface="微软雅黑"/>
+              </a:rPr>
+              <a:t>新华街</a:t>
+            </a:r>
+          </a:p>
+        </p:txBody>
+      </p:sp>
+      <p:sp>
+        <p:nvSpPr>
+          <p:cNvPr id="11" name="G102国道"/>
+          <p:cNvSpPr txBox="1"/>
+          <p:nvPr/>
+        </p:nvSpPr>
+        <p:spPr>
+          <a:xfrm rot="19101988">
+            <a:off x="14763668" y="10239188"/>
+            <a:ext cx="1183599" cy="291876"/>
+          </a:xfrm>
+          <a:prstGeom prst="rect">
+            <a:avLst/>
+          </a:prstGeom>
+          <a:noFill/>
+        </p:spPr>
+        <p:txBody>
+          <a:bodyPr wrap="none" anchor="t" lIns="0" rIns="0" tIns="0" bIns="0">
+            <a:noAutofit/>
+          </a:bodyPr>
+          <a:lstStyle/>
+          <a:p>
+            <a:pPr algn="ctr"/>
+            <a:r>
+              <a:rPr lang="zh-CN" sz="1728" b="0">
                 <a:solidFill>
                   <a:srgbClr val="5B5B5B"/>
                 </a:solidFill>
@@ -3497,7 +3541,7 @@
       </p:sp>
       <p:sp>
         <p:nvSpPr>
-          <p:cNvPr id="11" name="天台镇"/>
+          <p:cNvPr id="12" name="天台镇"/>
           <p:cNvSpPr txBox="1"/>
           <p:nvPr/>
         </p:nvSpPr>
@@ -3534,7 +3578,7 @@
       </p:sp>
       <p:sp>
         <p:nvSpPr>
-          <p:cNvPr id="12" name="万金塔乡"/>
+          <p:cNvPr id="13" name="万金塔乡"/>
           <p:cNvSpPr txBox="1"/>
           <p:nvPr/>
         </p:nvSpPr>
@@ -3571,7 +3615,7 @@
       </p:sp>
       <p:sp>
         <p:nvSpPr>
-          <p:cNvPr id="13" name="德惠西站"/>
+          <p:cNvPr id="14" name="德惠西站"/>
           <p:cNvSpPr txBox="1"/>
           <p:nvPr/>
         </p:nvSpPr>
@@ -3608,7 +3652,7 @@
       </p:sp>
       <p:sp>
         <p:nvSpPr>
-          <p:cNvPr id="14" name="龙凤采摘园"/>
+          <p:cNvPr id="15" name="龙凤采摘园"/>
           <p:cNvSpPr txBox="1"/>
           <p:nvPr/>
         </p:nvSpPr>
@@ -3645,7 +3689,7 @@
       </p:sp>
       <p:sp>
         <p:nvSpPr>
-          <p:cNvPr id="15" name="德惠市区"/>
+          <p:cNvPr id="16" name="德惠市区"/>
           <p:cNvSpPr txBox="1"/>
           <p:nvPr/>
         </p:nvSpPr>
@@ -3682,7 +3726,7 @@
       </p:sp>
       <p:sp>
         <p:nvSpPr>
-          <p:cNvPr id="16" name="红旗大市场"/>
+          <p:cNvPr id="17" name="红旗大市场"/>
           <p:cNvSpPr txBox="1"/>
           <p:nvPr/>
         </p:nvSpPr>
@@ -3726,7 +3770,7 @@
       </p:sp>
       <p:sp>
         <p:nvSpPr>
-          <p:cNvPr id="17" name="王三姐绿色生态园"/>
+          <p:cNvPr id="18" name="王三姐绿色生态园"/>
           <p:cNvSpPr txBox="1"/>
           <p:nvPr/>
         </p:nvSpPr>
@@ -3770,7 +3814,7 @@
       </p:sp>
       <p:sp>
         <p:nvSpPr>
-          <p:cNvPr id="18" name="新郎家"/>
+          <p:cNvPr id="19" name="新郎家"/>
           <p:cNvSpPr txBox="1"/>
           <p:nvPr/>
         </p:nvSpPr>
@@ -3814,7 +3858,7 @@
       </p:sp>
       <p:sp>
         <p:nvSpPr>
-          <p:cNvPr id="19" name="中国石油万金塔派出所北加油站"/>
+          <p:cNvPr id="20" name="中国石油万金塔派出所北加油站"/>
           <p:cNvSpPr txBox="1"/>
           <p:nvPr/>
         </p:nvSpPr>
@@ -3858,7 +3902,7 @@
       </p:sp>
       <p:sp>
         <p:nvSpPr>
-          <p:cNvPr id="20" name="新娘家"/>
+          <p:cNvPr id="21" name="新娘家"/>
           <p:cNvSpPr txBox="1"/>
           <p:nvPr/>
         </p:nvSpPr>
@@ -3902,7 +3946,7 @@
       </p:sp>
       <p:sp>
         <p:nvSpPr>
-          <p:cNvPr id="21" name="腰周家"/>
+          <p:cNvPr id="22" name="腰周家"/>
           <p:cNvSpPr txBox="1"/>
           <p:nvPr/>
         </p:nvSpPr>
@@ -3946,7 +3990,7 @@
       </p:sp>
       <p:sp>
         <p:nvSpPr>
-          <p:cNvPr id="22" name="德惠市人民政府"/>
+          <p:cNvPr id="23" name="德惠市人民政府"/>
           <p:cNvSpPr txBox="1"/>
           <p:nvPr/>
         </p:nvSpPr>
@@ -3990,7 +4034,7 @@
       </p:sp>
       <p:sp>
         <p:nvSpPr>
-          <p:cNvPr id="23" name="婚车路线图"/>
+          <p:cNvPr id="24" name="婚车路线图"/>
           <p:cNvSpPr txBox="1"/>
           <p:nvPr/>
         </p:nvSpPr>
@@ -4034,7 +4078,7 @@
       </p:sp>
       <p:sp>
         <p:nvSpPr>
-          <p:cNvPr id="24" name="万金塔加油站 → 腰周家 → 德惠市人民政府 → 万金塔加油站"/>
+          <p:cNvPr id="25" name="万金塔加油站 → 腰周家 → 德惠市人民政府 → 万金塔加油站"/>
           <p:cNvSpPr txBox="1"/>
           <p:nvPr/>
         </p:nvSpPr>
@@ -4071,7 +4115,7 @@
       </p:sp>
       <p:sp>
         <p:nvSpPr>
-          <p:cNvPr id="25" name="北"/>
+          <p:cNvPr id="26" name="北"/>
           <p:cNvSpPr txBox="1"/>
           <p:nvPr/>
         </p:nvSpPr>
@@ -4108,7 +4152,7 @@
       </p:sp>
       <p:sp>
         <p:nvSpPr>
-          <p:cNvPr id="26" name="图 例"/>
+          <p:cNvPr id="27" name="图 例"/>
           <p:cNvSpPr txBox="1"/>
           <p:nvPr/>
         </p:nvSpPr>
@@ -4145,7 +4189,7 @@
       </p:sp>
       <p:sp>
         <p:nvSpPr>
-          <p:cNvPr id="27" name="去新娘家"/>
+          <p:cNvPr id="28" name="去新娘家"/>
           <p:cNvSpPr txBox="1"/>
           <p:nvPr/>
         </p:nvSpPr>
@@ -4182,7 +4226,7 @@
       </p:sp>
       <p:sp>
         <p:nvSpPr>
-          <p:cNvPr id="28" name="去德惠市人民政府"/>
+          <p:cNvPr id="29" name="去德惠市人民政府"/>
           <p:cNvSpPr txBox="1"/>
           <p:nvPr/>
         </p:nvSpPr>
@@ -4219,7 +4263,7 @@
       </p:sp>
       <p:sp>
         <p:nvSpPr>
-          <p:cNvPr id="29" name="回新郎家"/>
+          <p:cNvPr id="30" name="回新郎家"/>
           <p:cNvSpPr txBox="1"/>
           <p:nvPr/>
         </p:nvSpPr>
@@ -4256,7 +4300,7 @@
       </p:sp>
       <p:sp>
         <p:nvSpPr>
-          <p:cNvPr id="30" name="新郎"/>
+          <p:cNvPr id="31" name="新郎"/>
           <p:cNvSpPr txBox="1"/>
           <p:nvPr/>
         </p:nvSpPr>
@@ -4293,7 +4337,7 @@
       </p:sp>
       <p:sp>
         <p:nvSpPr>
-          <p:cNvPr id="31" name="谢拾雨"/>
+          <p:cNvPr id="32" name="谢拾雨"/>
           <p:cNvSpPr txBox="1"/>
           <p:nvPr/>
         </p:nvSpPr>
@@ -4330,7 +4374,7 @@
       </p:sp>
       <p:sp>
         <p:nvSpPr>
-          <p:cNvPr id="32" name="新娘"/>
+          <p:cNvPr id="33" name="新娘"/>
           <p:cNvSpPr txBox="1"/>
           <p:nvPr/>
         </p:nvSpPr>
@@ -4367,7 +4411,7 @@
       </p:sp>
       <p:sp>
         <p:nvSpPr>
-          <p:cNvPr id="33" name="周心语"/>
+          <p:cNvPr id="34" name="周心语"/>
           <p:cNvSpPr txBox="1"/>
           <p:nvPr/>
         </p:nvSpPr>
@@ -4404,7 +4448,7 @@
       </p:sp>
       <p:sp>
         <p:nvSpPr>
-          <p:cNvPr id="34" name="2026.10.28"/>
+          <p:cNvPr id="35" name="2026.10.28"/>
           <p:cNvSpPr txBox="1"/>
           <p:nvPr/>
         </p:nvSpPr>
@@ -4441,7 +4485,7 @@
       </p:sp>
       <p:sp>
         <p:nvSpPr>
-          <p:cNvPr id="35" name="农历九月十九 · 星期三"/>
+          <p:cNvPr id="36" name="农历九月十九 · 星期三"/>
           <p:cNvSpPr txBox="1"/>
           <p:nvPr/>
         </p:nvSpPr>
@@ -4478,7 +4522,7 @@
       </p:sp>
       <p:sp>
         <p:nvSpPr>
-          <p:cNvPr id="36" name="时间安排"/>
+          <p:cNvPr id="37" name="时间安排"/>
           <p:cNvSpPr txBox="1"/>
           <p:nvPr/>
         </p:nvSpPr>
@@ -4515,7 +4559,7 @@
       </p:sp>
       <p:sp>
         <p:nvSpPr>
-          <p:cNvPr id="37" name="5:00 – 5:20"/>
+          <p:cNvPr id="38" name="5:00 – 5:20"/>
           <p:cNvSpPr txBox="1"/>
           <p:nvPr/>
         </p:nvSpPr>
@@ -4552,7 +4596,7 @@
       </p:sp>
       <p:sp>
         <p:nvSpPr>
-          <p:cNvPr id="38" name="到达万金塔集结扎花"/>
+          <p:cNvPr id="39" name="到达万金塔集结扎花"/>
           <p:cNvSpPr txBox="1"/>
           <p:nvPr/>
         </p:nvSpPr>
@@ -4589,7 +4633,7 @@
       </p:sp>
       <p:sp>
         <p:nvSpPr>
-          <p:cNvPr id="39" name="5:30"/>
+          <p:cNvPr id="40" name="5:30"/>
           <p:cNvSpPr txBox="1"/>
           <p:nvPr/>
         </p:nvSpPr>
@@ -4626,7 +4670,7 @@
       </p:sp>
       <p:sp>
         <p:nvSpPr>
-          <p:cNvPr id="40" name="从万金塔出发（男方）"/>
+          <p:cNvPr id="41" name="从万金塔出发（男方）"/>
           <p:cNvSpPr txBox="1"/>
           <p:nvPr/>
         </p:nvSpPr>
@@ -4663,7 +4707,7 @@
       </p:sp>
       <p:sp>
         <p:nvSpPr>
-          <p:cNvPr id="41" name="6:30"/>
+          <p:cNvPr id="42" name="6:30"/>
           <p:cNvSpPr txBox="1"/>
           <p:nvPr/>
         </p:nvSpPr>
@@ -4700,7 +4744,7 @@
       </p:sp>
       <p:sp>
         <p:nvSpPr>
-          <p:cNvPr id="42" name="到达腰周家（女方）"/>
+          <p:cNvPr id="43" name="到达腰周家（女方）"/>
           <p:cNvSpPr txBox="1"/>
           <p:nvPr/>
         </p:nvSpPr>
@@ -4737,7 +4781,7 @@
       </p:sp>
       <p:sp>
         <p:nvSpPr>
-          <p:cNvPr id="43" name="8:00"/>
+          <p:cNvPr id="44" name="8:00"/>
           <p:cNvSpPr txBox="1"/>
           <p:nvPr/>
         </p:nvSpPr>
@@ -4774,7 +4818,7 @@
       </p:sp>
       <p:sp>
         <p:nvSpPr>
-          <p:cNvPr id="44" name="从腰周家出发返回万金塔"/>
+          <p:cNvPr id="45" name="从腰周家出发返回万金塔"/>
           <p:cNvSpPr txBox="1"/>
           <p:nvPr/>
         </p:nvSpPr>
@@ -4811,7 +4855,7 @@
       </p:sp>
       <p:sp>
         <p:nvSpPr>
-          <p:cNvPr id="45" name="途经德惠市人民政府"/>
+          <p:cNvPr id="46" name="途经德惠市人民政府"/>
           <p:cNvSpPr txBox="1"/>
           <p:nvPr/>
         </p:nvSpPr>
@@ -4848,7 +4892,7 @@
       </p:sp>
       <p:sp>
         <p:nvSpPr>
-          <p:cNvPr id="46" name="感谢各位朋友，请按图示路线行驶"/>
+          <p:cNvPr id="47" name="感谢各位朋友，请按图示路线行驶"/>
           <p:cNvSpPr txBox="1"/>
           <p:nvPr/>
         </p:nvSpPr>

</xml_diff>

<commit_message>
Redraw the city route to match the detailed screenshot
- Leg to the government: 新华街 → right on 松柏路 at 红旗大市场 → north →
  east-southeast → south into 德惠市人民政府
- Return leg leaves the government northward, then northwest out of town
- Add 松柏路 and 中林石油加油站; move the government label below 松柏路

Co-Authored-By: Claude Opus 5.5 <noreply@anthropic.com>
Claude-Session: https://claude.ai/code/session_014xWo2Dszvks45w7evtNpHL
</commit_message>
<xml_diff>
--- a/wedding-route/wedding_route_map.pptx
+++ b/wedding-route/wedding_route_map.pptx
@@ -3458,8 +3458,8 @@
           <p:nvPr/>
         </p:nvSpPr>
         <p:spPr>
-          <a:xfrm rot="18842470">
-            <a:off x="12268244" y="9144409"/>
+          <a:xfrm rot="18846008">
+            <a:off x="12199247" y="9217803"/>
             <a:ext cx="893368" cy="316199"/>
           </a:xfrm>
           <a:prstGeom prst="rect">
@@ -3497,13 +3497,57 @@
       </p:sp>
       <p:sp>
         <p:nvSpPr>
-          <p:cNvPr id="11" name="G102国道"/>
+          <p:cNvPr id="11" name="松柏路"/>
           <p:cNvSpPr txBox="1"/>
           <p:nvPr/>
         </p:nvSpPr>
         <p:spPr>
-          <a:xfrm rot="19101988">
-            <a:off x="14763668" y="10239188"/>
+          <a:xfrm rot="1203366">
+            <a:off x="13325398" y="8704574"/>
+            <a:ext cx="767181" cy="267553"/>
+          </a:xfrm>
+          <a:prstGeom prst="rect">
+            <a:avLst/>
+          </a:prstGeom>
+          <a:noFill/>
+        </p:spPr>
+        <p:txBody>
+          <a:bodyPr wrap="none" anchor="t" lIns="0" rIns="0" tIns="0" bIns="0">
+            <a:noAutofit/>
+          </a:bodyPr>
+          <a:lstStyle/>
+          <a:p>
+            <a:pPr algn="ctr"/>
+            <a:r>
+              <a:rPr lang="zh-CN" sz="1584" b="0">
+                <a:solidFill>
+                  <a:srgbClr val="5B5B5B"/>
+                </a:solidFill>
+                <a:effectLst>
+                  <a:glow rad="27432">
+                    <a:srgbClr val="FFF3F7">
+                      <a:alpha val="90000"/>
+                    </a:srgbClr>
+                  </a:glow>
+                </a:effectLst>
+                <a:latin typeface="微软雅黑"/>
+                <a:ea typeface="微软雅黑"/>
+                <a:cs typeface="微软雅黑"/>
+              </a:rPr>
+              <a:t>松柏路</a:t>
+            </a:r>
+          </a:p>
+        </p:txBody>
+      </p:sp>
+      <p:sp>
+        <p:nvSpPr>
+          <p:cNvPr id="12" name="G102国道"/>
+          <p:cNvSpPr txBox="1"/>
+          <p:nvPr/>
+        </p:nvSpPr>
+        <p:spPr>
+          <a:xfrm rot="19449741">
+            <a:off x="14737295" y="10328924"/>
             <a:ext cx="1183599" cy="291876"/>
           </a:xfrm>
           <a:prstGeom prst="rect">
@@ -3541,7 +3585,7 @@
       </p:sp>
       <p:sp>
         <p:nvSpPr>
-          <p:cNvPr id="12" name="天台镇"/>
+          <p:cNvPr id="13" name="天台镇"/>
           <p:cNvSpPr txBox="1"/>
           <p:nvPr/>
         </p:nvSpPr>
@@ -3578,7 +3622,7 @@
       </p:sp>
       <p:sp>
         <p:nvSpPr>
-          <p:cNvPr id="13" name="万金塔乡"/>
+          <p:cNvPr id="14" name="万金塔乡"/>
           <p:cNvSpPr txBox="1"/>
           <p:nvPr/>
         </p:nvSpPr>
@@ -3615,7 +3659,7 @@
       </p:sp>
       <p:sp>
         <p:nvSpPr>
-          <p:cNvPr id="14" name="德惠西站"/>
+          <p:cNvPr id="15" name="德惠西站"/>
           <p:cNvSpPr txBox="1"/>
           <p:nvPr/>
         </p:nvSpPr>
@@ -3652,7 +3696,7 @@
       </p:sp>
       <p:sp>
         <p:nvSpPr>
-          <p:cNvPr id="15" name="龙凤采摘园"/>
+          <p:cNvPr id="16" name="龙凤采摘园"/>
           <p:cNvSpPr txBox="1"/>
           <p:nvPr/>
         </p:nvSpPr>
@@ -3689,7 +3733,7 @@
       </p:sp>
       <p:sp>
         <p:nvSpPr>
-          <p:cNvPr id="16" name="德惠市区"/>
+          <p:cNvPr id="17" name="德惠市区"/>
           <p:cNvSpPr txBox="1"/>
           <p:nvPr/>
         </p:nvSpPr>
@@ -3726,13 +3770,13 @@
       </p:sp>
       <p:sp>
         <p:nvSpPr>
-          <p:cNvPr id="17" name="红旗大市场"/>
+          <p:cNvPr id="18" name="红旗大市场"/>
           <p:cNvSpPr txBox="1"/>
           <p:nvPr/>
         </p:nvSpPr>
         <p:spPr>
           <a:xfrm>
-            <a:off x="12399264" y="7413260"/>
+            <a:off x="12216384" y="7577852"/>
             <a:ext cx="1229868" cy="267553"/>
           </a:xfrm>
           <a:prstGeom prst="rect">
@@ -3770,13 +3814,57 @@
       </p:sp>
       <p:sp>
         <p:nvSpPr>
-          <p:cNvPr id="18" name="王三姐绿色生态园"/>
+          <p:cNvPr id="19" name="中林石油加油站"/>
           <p:cNvSpPr txBox="1"/>
           <p:nvPr/>
         </p:nvSpPr>
         <p:spPr>
           <a:xfrm>
-            <a:off x="14228064" y="6169676"/>
+            <a:off x="12847320" y="5840492"/>
+            <a:ext cx="1692554" cy="267553"/>
+          </a:xfrm>
+          <a:prstGeom prst="rect">
+            <a:avLst/>
+          </a:prstGeom>
+          <a:noFill/>
+        </p:spPr>
+        <p:txBody>
+          <a:bodyPr wrap="none" anchor="t" lIns="0" rIns="0" tIns="0" bIns="0">
+            <a:noAutofit/>
+          </a:bodyPr>
+          <a:lstStyle/>
+          <a:p>
+            <a:pPr algn="l"/>
+            <a:r>
+              <a:rPr lang="zh-CN" sz="1584" b="0">
+                <a:solidFill>
+                  <a:srgbClr val="2F7BF6"/>
+                </a:solidFill>
+                <a:effectLst>
+                  <a:glow rad="27432">
+                    <a:srgbClr val="FFF3F7">
+                      <a:alpha val="90000"/>
+                    </a:srgbClr>
+                  </a:glow>
+                </a:effectLst>
+                <a:latin typeface="微软雅黑"/>
+                <a:ea typeface="微软雅黑"/>
+                <a:cs typeface="微软雅黑"/>
+              </a:rPr>
+              <a:t>中林石油加油站</a:t>
+            </a:r>
+          </a:p>
+        </p:txBody>
+      </p:sp>
+      <p:sp>
+        <p:nvSpPr>
+          <p:cNvPr id="20" name="王三姐绿色生态园"/>
+          <p:cNvSpPr txBox="1"/>
+          <p:nvPr/>
+        </p:nvSpPr>
+        <p:spPr>
+          <a:xfrm>
+            <a:off x="14484096" y="6334268"/>
             <a:ext cx="1923897" cy="267553"/>
           </a:xfrm>
           <a:prstGeom prst="rect">
@@ -3814,7 +3902,7 @@
       </p:sp>
       <p:sp>
         <p:nvSpPr>
-          <p:cNvPr id="19" name="新郎家"/>
+          <p:cNvPr id="21" name="新郎家"/>
           <p:cNvSpPr txBox="1"/>
           <p:nvPr/>
         </p:nvSpPr>
@@ -3858,7 +3946,7 @@
       </p:sp>
       <p:sp>
         <p:nvSpPr>
-          <p:cNvPr id="20" name="中国石油万金塔派出所北加油站"/>
+          <p:cNvPr id="22" name="中国石油万金塔派出所北加油站"/>
           <p:cNvSpPr txBox="1"/>
           <p:nvPr/>
         </p:nvSpPr>
@@ -3902,7 +3990,7 @@
       </p:sp>
       <p:sp>
         <p:nvSpPr>
-          <p:cNvPr id="21" name="新娘家"/>
+          <p:cNvPr id="23" name="新娘家"/>
           <p:cNvSpPr txBox="1"/>
           <p:nvPr/>
         </p:nvSpPr>
@@ -3946,7 +4034,7 @@
       </p:sp>
       <p:sp>
         <p:nvSpPr>
-          <p:cNvPr id="22" name="腰周家"/>
+          <p:cNvPr id="24" name="腰周家"/>
           <p:cNvSpPr txBox="1"/>
           <p:nvPr/>
         </p:nvSpPr>
@@ -3990,13 +4078,13 @@
       </p:sp>
       <p:sp>
         <p:nvSpPr>
-          <p:cNvPr id="23" name="德惠市人民政府"/>
+          <p:cNvPr id="25" name="德惠市人民政府"/>
           <p:cNvSpPr txBox="1"/>
           <p:nvPr/>
         </p:nvSpPr>
         <p:spPr>
           <a:xfrm>
-            <a:off x="13927683" y="8540752"/>
+            <a:off x="13936827" y="8924800"/>
             <a:ext cx="2575864" cy="413491"/>
           </a:xfrm>
           <a:prstGeom prst="rect">
@@ -4034,7 +4122,7 @@
       </p:sp>
       <p:sp>
         <p:nvSpPr>
-          <p:cNvPr id="24" name="婚车路线图"/>
+          <p:cNvPr id="26" name="婚车路线图"/>
           <p:cNvSpPr txBox="1"/>
           <p:nvPr/>
         </p:nvSpPr>
@@ -4078,7 +4166,7 @@
       </p:sp>
       <p:sp>
         <p:nvSpPr>
-          <p:cNvPr id="25" name="万金塔加油站 → 腰周家 → 德惠市人民政府 → 万金塔加油站"/>
+          <p:cNvPr id="27" name="万金塔加油站 → 腰周家 → 德惠市人民政府 → 万金塔加油站"/>
           <p:cNvSpPr txBox="1"/>
           <p:nvPr/>
         </p:nvSpPr>
@@ -4115,7 +4203,7 @@
       </p:sp>
       <p:sp>
         <p:nvSpPr>
-          <p:cNvPr id="26" name="北"/>
+          <p:cNvPr id="28" name="北"/>
           <p:cNvSpPr txBox="1"/>
           <p:nvPr/>
         </p:nvSpPr>
@@ -4152,7 +4240,7 @@
       </p:sp>
       <p:sp>
         <p:nvSpPr>
-          <p:cNvPr id="27" name="图 例"/>
+          <p:cNvPr id="29" name="图 例"/>
           <p:cNvSpPr txBox="1"/>
           <p:nvPr/>
         </p:nvSpPr>
@@ -4189,7 +4277,7 @@
       </p:sp>
       <p:sp>
         <p:nvSpPr>
-          <p:cNvPr id="28" name="去新娘家"/>
+          <p:cNvPr id="30" name="去新娘家"/>
           <p:cNvSpPr txBox="1"/>
           <p:nvPr/>
         </p:nvSpPr>
@@ -4226,7 +4314,7 @@
       </p:sp>
       <p:sp>
         <p:nvSpPr>
-          <p:cNvPr id="29" name="去德惠市人民政府"/>
+          <p:cNvPr id="31" name="去德惠市人民政府"/>
           <p:cNvSpPr txBox="1"/>
           <p:nvPr/>
         </p:nvSpPr>
@@ -4263,7 +4351,7 @@
       </p:sp>
       <p:sp>
         <p:nvSpPr>
-          <p:cNvPr id="30" name="回新郎家"/>
+          <p:cNvPr id="32" name="回新郎家"/>
           <p:cNvSpPr txBox="1"/>
           <p:nvPr/>
         </p:nvSpPr>
@@ -4300,7 +4388,7 @@
       </p:sp>
       <p:sp>
         <p:nvSpPr>
-          <p:cNvPr id="31" name="新郎"/>
+          <p:cNvPr id="33" name="新郎"/>
           <p:cNvSpPr txBox="1"/>
           <p:nvPr/>
         </p:nvSpPr>
@@ -4337,7 +4425,7 @@
       </p:sp>
       <p:sp>
         <p:nvSpPr>
-          <p:cNvPr id="32" name="谢拾雨"/>
+          <p:cNvPr id="34" name="谢拾雨"/>
           <p:cNvSpPr txBox="1"/>
           <p:nvPr/>
         </p:nvSpPr>
@@ -4374,7 +4462,7 @@
       </p:sp>
       <p:sp>
         <p:nvSpPr>
-          <p:cNvPr id="33" name="新娘"/>
+          <p:cNvPr id="35" name="新娘"/>
           <p:cNvSpPr txBox="1"/>
           <p:nvPr/>
         </p:nvSpPr>
@@ -4411,7 +4499,7 @@
       </p:sp>
       <p:sp>
         <p:nvSpPr>
-          <p:cNvPr id="34" name="周心语"/>
+          <p:cNvPr id="36" name="周心语"/>
           <p:cNvSpPr txBox="1"/>
           <p:nvPr/>
         </p:nvSpPr>
@@ -4448,7 +4536,7 @@
       </p:sp>
       <p:sp>
         <p:nvSpPr>
-          <p:cNvPr id="35" name="2026.10.28"/>
+          <p:cNvPr id="37" name="2026.10.28"/>
           <p:cNvSpPr txBox="1"/>
           <p:nvPr/>
         </p:nvSpPr>
@@ -4485,7 +4573,7 @@
       </p:sp>
       <p:sp>
         <p:nvSpPr>
-          <p:cNvPr id="36" name="农历九月十九 · 星期三"/>
+          <p:cNvPr id="38" name="农历九月十九 · 星期三"/>
           <p:cNvSpPr txBox="1"/>
           <p:nvPr/>
         </p:nvSpPr>
@@ -4522,7 +4610,7 @@
       </p:sp>
       <p:sp>
         <p:nvSpPr>
-          <p:cNvPr id="37" name="时间安排"/>
+          <p:cNvPr id="39" name="时间安排"/>
           <p:cNvSpPr txBox="1"/>
           <p:nvPr/>
         </p:nvSpPr>
@@ -4559,7 +4647,7 @@
       </p:sp>
       <p:sp>
         <p:nvSpPr>
-          <p:cNvPr id="38" name="5:00 – 5:20"/>
+          <p:cNvPr id="40" name="5:00 – 5:20"/>
           <p:cNvSpPr txBox="1"/>
           <p:nvPr/>
         </p:nvSpPr>
@@ -4596,7 +4684,7 @@
       </p:sp>
       <p:sp>
         <p:nvSpPr>
-          <p:cNvPr id="39" name="到达万金塔集结扎花"/>
+          <p:cNvPr id="41" name="到达万金塔集结扎花"/>
           <p:cNvSpPr txBox="1"/>
           <p:nvPr/>
         </p:nvSpPr>
@@ -4633,7 +4721,7 @@
       </p:sp>
       <p:sp>
         <p:nvSpPr>
-          <p:cNvPr id="40" name="5:30"/>
+          <p:cNvPr id="42" name="5:30"/>
           <p:cNvSpPr txBox="1"/>
           <p:nvPr/>
         </p:nvSpPr>
@@ -4670,7 +4758,7 @@
       </p:sp>
       <p:sp>
         <p:nvSpPr>
-          <p:cNvPr id="41" name="从万金塔出发（男方）"/>
+          <p:cNvPr id="43" name="从万金塔出发（男方）"/>
           <p:cNvSpPr txBox="1"/>
           <p:nvPr/>
         </p:nvSpPr>
@@ -4707,7 +4795,7 @@
       </p:sp>
       <p:sp>
         <p:nvSpPr>
-          <p:cNvPr id="42" name="6:30"/>
+          <p:cNvPr id="44" name="6:30"/>
           <p:cNvSpPr txBox="1"/>
           <p:nvPr/>
         </p:nvSpPr>
@@ -4744,7 +4832,7 @@
       </p:sp>
       <p:sp>
         <p:nvSpPr>
-          <p:cNvPr id="43" name="到达腰周家（女方）"/>
+          <p:cNvPr id="45" name="到达腰周家（女方）"/>
           <p:cNvSpPr txBox="1"/>
           <p:nvPr/>
         </p:nvSpPr>
@@ -4781,7 +4869,7 @@
       </p:sp>
       <p:sp>
         <p:nvSpPr>
-          <p:cNvPr id="44" name="8:00"/>
+          <p:cNvPr id="46" name="8:00"/>
           <p:cNvSpPr txBox="1"/>
           <p:nvPr/>
         </p:nvSpPr>
@@ -4818,7 +4906,7 @@
       </p:sp>
       <p:sp>
         <p:nvSpPr>
-          <p:cNvPr id="45" name="从腰周家出发返回万金塔"/>
+          <p:cNvPr id="47" name="从腰周家出发返回万金塔"/>
           <p:cNvSpPr txBox="1"/>
           <p:nvPr/>
         </p:nvSpPr>
@@ -4855,7 +4943,7 @@
       </p:sp>
       <p:sp>
         <p:nvSpPr>
-          <p:cNvPr id="46" name="途经德惠市人民政府"/>
+          <p:cNvPr id="48" name="途经德惠市人民政府"/>
           <p:cNvSpPr txBox="1"/>
           <p:nvPr/>
         </p:nvSpPr>
@@ -4892,7 +4980,7 @@
       </p:sp>
       <p:sp>
         <p:nvSpPr>
-          <p:cNvPr id="47" name="感谢各位朋友，请按图示路线行驶"/>
+          <p:cNvPr id="49" name="感谢各位朋友，请按图示路线行驶"/>
           <p:cNvSpPr txBox="1"/>
           <p:nvPr/>
         </p:nvSpPr>

</xml_diff>

<commit_message>
Trace the city map directly from the Amap screenshot
Replace the hand-placed schematic for everything east of the S303 turn with
coordinates traced from the user's Amap screenshots (amap() / amap_near()
convert screenshot pixels to canvas at one fixed scale), so road shapes and
proportions match the real map. Also draw both railways, 北环城路 and the
real 松柏路 / G102 junction; fade context lines out at the map's top edge
and 德农路 at the info card; thin the city roads and arrows to fit the
traced detail; move the legend up to clear 303省道 east.

Co-Authored-By: Claude Opus 5.5 <noreply@anthropic.com>
Claude-Session: https://claude.ai/code/session_014xWo2Dszvks45w7evtNpHL
</commit_message>
<xml_diff>
--- a/wedding-route/wedding_route_map.pptx
+++ b/wedding-route/wedding_route_map.pptx
@@ -3106,8 +3106,8 @@
           <p:nvPr/>
         </p:nvSpPr>
         <p:spPr>
-          <a:xfrm rot="342636">
-            <a:off x="5116844" y="2956813"/>
+          <a:xfrm rot="366093">
+            <a:off x="5114377" y="2874554"/>
             <a:ext cx="1112093" cy="316199"/>
           </a:xfrm>
           <a:prstGeom prst="rect">
@@ -3150,9 +3150,9 @@
           <p:nvPr/>
         </p:nvSpPr>
         <p:spPr>
-          <a:xfrm rot="342636">
-            <a:off x="10146044" y="3596893"/>
-            <a:ext cx="1112093" cy="316199"/>
+          <a:xfrm rot="162959">
+            <a:off x="10525052" y="3519983"/>
+            <a:ext cx="1032174" cy="291876"/>
           </a:xfrm>
           <a:prstGeom prst="rect">
             <a:avLst/>
@@ -3167,7 +3167,7 @@
           <a:p>
             <a:pPr algn="ctr"/>
             <a:r>
-              <a:rPr lang="zh-CN" sz="1872" b="0">
+              <a:rPr lang="zh-CN" sz="1728" b="0">
                 <a:solidFill>
                   <a:srgbClr val="5B5B5B"/>
                 </a:solidFill>
@@ -3189,14 +3189,14 @@
       </p:sp>
       <p:sp>
         <p:nvSpPr>
-          <p:cNvPr id="4" name="西环城路"/>
+          <p:cNvPr id="4" name="北环城路"/>
           <p:cNvSpPr txBox="1"/>
           <p:nvPr/>
         </p:nvSpPr>
         <p:spPr>
-          <a:xfrm rot="2972266">
-            <a:off x="10268905" y="6506640"/>
-            <a:ext cx="1082649" cy="291876"/>
+          <a:xfrm rot="696201">
+            <a:off x="15543232" y="5483264"/>
+            <a:ext cx="998524" cy="267553"/>
           </a:xfrm>
           <a:prstGeom prst="rect">
             <a:avLst/>
@@ -3211,7 +3211,7 @@
           <a:p>
             <a:pPr algn="ctr"/>
             <a:r>
-              <a:rPr lang="zh-CN" sz="1728" b="0">
+              <a:rPr lang="zh-CN" sz="1584" b="0">
                 <a:solidFill>
                   <a:srgbClr val="5B5B5B"/>
                 </a:solidFill>
@@ -3226,21 +3226,21 @@
                 <a:ea typeface="微软雅黑"/>
                 <a:cs typeface="微软雅黑"/>
               </a:rPr>
-              <a:t>西环城路</a:t>
-            </a:r>
-          </a:p>
-        </p:txBody>
-      </p:sp>
-      <p:sp>
-        <p:nvSpPr>
-          <p:cNvPr id="5" name="德环路"/>
+              <a:t>北环城路</a:t>
+            </a:r>
+          </a:p>
+        </p:txBody>
+      </p:sp>
+      <p:sp>
+        <p:nvSpPr>
+          <p:cNvPr id="5" name="京哈高速"/>
           <p:cNvSpPr txBox="1"/>
           <p:nvPr/>
         </p:nvSpPr>
         <p:spPr>
-          <a:xfrm rot="4781709">
-            <a:off x="10298791" y="9034031"/>
-            <a:ext cx="830275" cy="291876"/>
+          <a:xfrm rot="17042175">
+            <a:off x="11388265" y="5402997"/>
+            <a:ext cx="998524" cy="267553"/>
           </a:xfrm>
           <a:prstGeom prst="rect">
             <a:avLst/>
@@ -3255,7 +3255,139 @@
           <a:p>
             <a:pPr algn="ctr"/>
             <a:r>
-              <a:rPr lang="zh-CN" sz="1728" b="0">
+              <a:rPr lang="zh-CN" sz="1584" b="0">
+                <a:solidFill>
+                  <a:srgbClr val="5D6F9C"/>
+                </a:solidFill>
+                <a:effectLst>
+                  <a:glow rad="27432">
+                    <a:srgbClr val="FFF3F7">
+                      <a:alpha val="90000"/>
+                    </a:srgbClr>
+                  </a:glow>
+                </a:effectLst>
+                <a:latin typeface="微软雅黑"/>
+                <a:ea typeface="微软雅黑"/>
+                <a:cs typeface="微软雅黑"/>
+              </a:rPr>
+              <a:t>京哈高速</a:t>
+            </a:r>
+          </a:p>
+        </p:txBody>
+      </p:sp>
+      <p:sp>
+        <p:nvSpPr>
+          <p:cNvPr id="6" name="京哈高速"/>
+          <p:cNvSpPr txBox="1"/>
+          <p:nvPr/>
+        </p:nvSpPr>
+        <p:spPr>
+          <a:xfrm rot="17306097">
+            <a:off x="9403067" y="9572981"/>
+            <a:ext cx="998524" cy="267553"/>
+          </a:xfrm>
+          <a:prstGeom prst="rect">
+            <a:avLst/>
+          </a:prstGeom>
+          <a:noFill/>
+        </p:spPr>
+        <p:txBody>
+          <a:bodyPr wrap="none" anchor="t" lIns="0" rIns="0" tIns="0" bIns="0">
+            <a:noAutofit/>
+          </a:bodyPr>
+          <a:lstStyle/>
+          <a:p>
+            <a:pPr algn="ctr"/>
+            <a:r>
+              <a:rPr lang="zh-CN" sz="1584" b="0">
+                <a:solidFill>
+                  <a:srgbClr val="5D6F9C"/>
+                </a:solidFill>
+                <a:effectLst>
+                  <a:glow rad="27432">
+                    <a:srgbClr val="FFF3F7">
+                      <a:alpha val="90000"/>
+                    </a:srgbClr>
+                  </a:glow>
+                </a:effectLst>
+                <a:latin typeface="微软雅黑"/>
+                <a:ea typeface="微软雅黑"/>
+                <a:cs typeface="微软雅黑"/>
+              </a:rPr>
+              <a:t>京哈高速</a:t>
+            </a:r>
+          </a:p>
+        </p:txBody>
+      </p:sp>
+      <p:sp>
+        <p:nvSpPr>
+          <p:cNvPr id="7" name="德农路"/>
+          <p:cNvSpPr txBox="1"/>
+          <p:nvPr/>
+        </p:nvSpPr>
+        <p:spPr>
+          <a:xfrm rot="21219588">
+            <a:off x="9204650" y="8760790"/>
+            <a:ext cx="767181" cy="267553"/>
+          </a:xfrm>
+          <a:prstGeom prst="rect">
+            <a:avLst/>
+          </a:prstGeom>
+          <a:noFill/>
+        </p:spPr>
+        <p:txBody>
+          <a:bodyPr wrap="none" anchor="t" lIns="0" rIns="0" tIns="0" bIns="0">
+            <a:noAutofit/>
+          </a:bodyPr>
+          <a:lstStyle/>
+          <a:p>
+            <a:pPr algn="ctr"/>
+            <a:r>
+              <a:rPr lang="zh-CN" sz="1584" b="0">
+                <a:solidFill>
+                  <a:srgbClr val="5B5B5B"/>
+                </a:solidFill>
+                <a:effectLst>
+                  <a:glow rad="27432">
+                    <a:srgbClr val="FFF3F7">
+                      <a:alpha val="90000"/>
+                    </a:srgbClr>
+                  </a:glow>
+                </a:effectLst>
+                <a:latin typeface="微软雅黑"/>
+                <a:ea typeface="微软雅黑"/>
+                <a:cs typeface="微软雅黑"/>
+              </a:rPr>
+              <a:t>德农路</a:t>
+            </a:r>
+          </a:p>
+        </p:txBody>
+      </p:sp>
+      <p:sp>
+        <p:nvSpPr>
+          <p:cNvPr id="8" name="德环路"/>
+          <p:cNvSpPr txBox="1"/>
+          <p:nvPr/>
+        </p:nvSpPr>
+        <p:spPr>
+          <a:xfrm rot="4797609">
+            <a:off x="11327088" y="9352895"/>
+            <a:ext cx="767181" cy="267553"/>
+          </a:xfrm>
+          <a:prstGeom prst="rect">
+            <a:avLst/>
+          </a:prstGeom>
+          <a:noFill/>
+        </p:spPr>
+        <p:txBody>
+          <a:bodyPr wrap="none" anchor="t" lIns="0" rIns="0" tIns="0" bIns="0">
+            <a:noAutofit/>
+          </a:bodyPr>
+          <a:lstStyle/>
+          <a:p>
+            <a:pPr algn="ctr"/>
+            <a:r>
+              <a:rPr lang="zh-CN" sz="1584" b="0">
                 <a:solidFill>
                   <a:srgbClr val="5B5B5B"/>
                 </a:solidFill>
@@ -3277,14 +3409,14 @@
       </p:sp>
       <p:sp>
         <p:nvSpPr>
-          <p:cNvPr id="6" name="德农环路"/>
+          <p:cNvPr id="9" name="德农环路"/>
           <p:cNvSpPr txBox="1"/>
           <p:nvPr/>
         </p:nvSpPr>
         <p:spPr>
-          <a:xfrm rot="810994">
-            <a:off x="12263622" y="9869318"/>
-            <a:ext cx="1082649" cy="291876"/>
+          <a:xfrm rot="20810206">
+            <a:off x="13377357" y="10453711"/>
+            <a:ext cx="998524" cy="267553"/>
           </a:xfrm>
           <a:prstGeom prst="rect">
             <a:avLst/>
@@ -3299,7 +3431,7 @@
           <a:p>
             <a:pPr algn="ctr"/>
             <a:r>
-              <a:rPr lang="zh-CN" sz="1728" b="0">
+              <a:rPr lang="zh-CN" sz="1584" b="0">
                 <a:solidFill>
                   <a:srgbClr val="5B5B5B"/>
                 </a:solidFill>
@@ -3321,14 +3453,14 @@
       </p:sp>
       <p:sp>
         <p:nvSpPr>
-          <p:cNvPr id="7" name="京哈高速"/>
+          <p:cNvPr id="10" name="新华街"/>
           <p:cNvSpPr txBox="1"/>
           <p:nvPr/>
         </p:nvSpPr>
         <p:spPr>
-          <a:xfrm rot="16866034">
-            <a:off x="11382527" y="2916662"/>
-            <a:ext cx="1082649" cy="291876"/>
+          <a:xfrm rot="18918785">
+            <a:off x="12375957" y="9587202"/>
+            <a:ext cx="830275" cy="291876"/>
           </a:xfrm>
           <a:prstGeom prst="rect">
             <a:avLst/>
@@ -3344,138 +3476,6 @@
             <a:pPr algn="ctr"/>
             <a:r>
               <a:rPr lang="zh-CN" sz="1728" b="0">
-                <a:solidFill>
-                  <a:srgbClr val="5D6F9C"/>
-                </a:solidFill>
-                <a:effectLst>
-                  <a:glow rad="27432">
-                    <a:srgbClr val="FFF3F7">
-                      <a:alpha val="90000"/>
-                    </a:srgbClr>
-                  </a:glow>
-                </a:effectLst>
-                <a:latin typeface="微软雅黑"/>
-                <a:ea typeface="微软雅黑"/>
-                <a:cs typeface="微软雅黑"/>
-              </a:rPr>
-              <a:t>京哈高速</a:t>
-            </a:r>
-          </a:p>
-        </p:txBody>
-      </p:sp>
-      <p:sp>
-        <p:nvSpPr>
-          <p:cNvPr id="8" name="京哈高速"/>
-          <p:cNvSpPr txBox="1"/>
-          <p:nvPr/>
-        </p:nvSpPr>
-        <p:spPr>
-          <a:xfrm rot="17306097">
-            <a:off x="8975721" y="9223603"/>
-            <a:ext cx="1082649" cy="291876"/>
-          </a:xfrm>
-          <a:prstGeom prst="rect">
-            <a:avLst/>
-          </a:prstGeom>
-          <a:noFill/>
-        </p:spPr>
-        <p:txBody>
-          <a:bodyPr wrap="none" anchor="t" lIns="0" rIns="0" tIns="0" bIns="0">
-            <a:noAutofit/>
-          </a:bodyPr>
-          <a:lstStyle/>
-          <a:p>
-            <a:pPr algn="ctr"/>
-            <a:r>
-              <a:rPr lang="zh-CN" sz="1728" b="0">
-                <a:solidFill>
-                  <a:srgbClr val="5D6F9C"/>
-                </a:solidFill>
-                <a:effectLst>
-                  <a:glow rad="27432">
-                    <a:srgbClr val="FFF3F7">
-                      <a:alpha val="90000"/>
-                    </a:srgbClr>
-                  </a:glow>
-                </a:effectLst>
-                <a:latin typeface="微软雅黑"/>
-                <a:ea typeface="微软雅黑"/>
-                <a:cs typeface="微软雅黑"/>
-              </a:rPr>
-              <a:t>京哈高速</a:t>
-            </a:r>
-          </a:p>
-        </p:txBody>
-      </p:sp>
-      <p:sp>
-        <p:nvSpPr>
-          <p:cNvPr id="9" name="德农路"/>
-          <p:cNvSpPr txBox="1"/>
-          <p:nvPr/>
-        </p:nvSpPr>
-        <p:spPr>
-          <a:xfrm rot="20986389">
-            <a:off x="9151806" y="8210670"/>
-            <a:ext cx="830275" cy="291876"/>
-          </a:xfrm>
-          <a:prstGeom prst="rect">
-            <a:avLst/>
-          </a:prstGeom>
-          <a:noFill/>
-        </p:spPr>
-        <p:txBody>
-          <a:bodyPr wrap="none" anchor="t" lIns="0" rIns="0" tIns="0" bIns="0">
-            <a:noAutofit/>
-          </a:bodyPr>
-          <a:lstStyle/>
-          <a:p>
-            <a:pPr algn="ctr"/>
-            <a:r>
-              <a:rPr lang="zh-CN" sz="1728" b="0">
-                <a:solidFill>
-                  <a:srgbClr val="5B5B5B"/>
-                </a:solidFill>
-                <a:effectLst>
-                  <a:glow rad="27432">
-                    <a:srgbClr val="FFF3F7">
-                      <a:alpha val="90000"/>
-                    </a:srgbClr>
-                  </a:glow>
-                </a:effectLst>
-                <a:latin typeface="微软雅黑"/>
-                <a:ea typeface="微软雅黑"/>
-                <a:cs typeface="微软雅黑"/>
-              </a:rPr>
-              <a:t>德农路</a:t>
-            </a:r>
-          </a:p>
-        </p:txBody>
-      </p:sp>
-      <p:sp>
-        <p:nvSpPr>
-          <p:cNvPr id="10" name="新华街"/>
-          <p:cNvSpPr txBox="1"/>
-          <p:nvPr/>
-        </p:nvSpPr>
-        <p:spPr>
-          <a:xfrm rot="18846008">
-            <a:off x="12199247" y="9217803"/>
-            <a:ext cx="893368" cy="316199"/>
-          </a:xfrm>
-          <a:prstGeom prst="rect">
-            <a:avLst/>
-          </a:prstGeom>
-          <a:noFill/>
-        </p:spPr>
-        <p:txBody>
-          <a:bodyPr wrap="none" anchor="t" lIns="0" rIns="0" tIns="0" bIns="0">
-            <a:noAutofit/>
-          </a:bodyPr>
-          <a:lstStyle/>
-          <a:p>
-            <a:pPr algn="ctr"/>
-            <a:r>
-              <a:rPr lang="zh-CN" sz="1872" b="0">
                 <a:solidFill>
                   <a:srgbClr val="5B5B5B"/>
                 </a:solidFill>
@@ -3502,8 +3502,8 @@
           <p:nvPr/>
         </p:nvSpPr>
         <p:spPr>
-          <a:xfrm rot="1203366">
-            <a:off x="13325398" y="8704574"/>
+          <a:xfrm rot="1416617">
+            <a:off x="11835852" y="8181564"/>
             <a:ext cx="767181" cy="267553"/>
           </a:xfrm>
           <a:prstGeom prst="rect">
@@ -3546,9 +3546,9 @@
           <p:nvPr/>
         </p:nvSpPr>
         <p:spPr>
-          <a:xfrm rot="19449741">
-            <a:off x="14737295" y="10328924"/>
-            <a:ext cx="1183599" cy="291876"/>
+          <a:xfrm rot="18959723">
+            <a:off x="14714031" y="9781359"/>
+            <a:ext cx="1091062" cy="267553"/>
           </a:xfrm>
           <a:prstGeom prst="rect">
             <a:avLst/>
@@ -3563,7 +3563,7 @@
           <a:p>
             <a:pPr algn="ctr"/>
             <a:r>
-              <a:rPr lang="zh-CN" sz="1728" b="0">
+              <a:rPr lang="zh-CN" sz="1584" b="0">
                 <a:solidFill>
                   <a:srgbClr val="5B5B5B"/>
                 </a:solidFill>
@@ -3591,7 +3591,7 @@
         </p:nvSpPr>
         <p:spPr>
           <a:xfrm>
-            <a:off x="6471208" y="3898782"/>
+            <a:off x="6471208" y="3752478"/>
             <a:ext cx="956462" cy="340522"/>
           </a:xfrm>
           <a:prstGeom prst="rect">
@@ -3628,7 +3628,7 @@
         </p:nvSpPr>
         <p:spPr>
           <a:xfrm>
-            <a:off x="640080" y="2511015"/>
+            <a:off x="640080" y="2437863"/>
             <a:ext cx="1082649" cy="291876"/>
           </a:xfrm>
           <a:prstGeom prst="rect">
@@ -3665,8 +3665,8 @@
         </p:nvSpPr>
         <p:spPr>
           <a:xfrm>
-            <a:off x="12124944" y="6653247"/>
-            <a:ext cx="1082649" cy="291876"/>
+            <a:off x="12316968" y="6901196"/>
+            <a:ext cx="998524" cy="267553"/>
           </a:xfrm>
           <a:prstGeom prst="rect">
             <a:avLst/>
@@ -3681,10 +3681,17 @@
           <a:p>
             <a:pPr algn="l"/>
             <a:r>
-              <a:rPr lang="zh-CN" sz="1728" b="0">
-                <a:solidFill>
-                  <a:srgbClr val="4A4A4A"/>
-                </a:solidFill>
+              <a:rPr lang="zh-CN" sz="1584" b="0">
+                <a:solidFill>
+                  <a:srgbClr val="2F6FD6"/>
+                </a:solidFill>
+                <a:effectLst>
+                  <a:glow rad="27432">
+                    <a:srgbClr val="FFF3F7">
+                      <a:alpha val="90000"/>
+                    </a:srgbClr>
+                  </a:glow>
+                </a:effectLst>
                 <a:latin typeface="微软雅黑"/>
                 <a:ea typeface="微软雅黑"/>
                 <a:cs typeface="微软雅黑"/>
@@ -3696,87 +3703,13 @@
       </p:sp>
       <p:sp>
         <p:nvSpPr>
-          <p:cNvPr id="16" name="龙凤采摘园"/>
+          <p:cNvPr id="16" name="红旗大市场"/>
           <p:cNvSpPr txBox="1"/>
           <p:nvPr/>
         </p:nvSpPr>
         <p:spPr>
           <a:xfrm>
-            <a:off x="11337417" y="8052809"/>
-            <a:ext cx="1282446" cy="279714"/>
-          </a:xfrm>
-          <a:prstGeom prst="rect">
-            <a:avLst/>
-          </a:prstGeom>
-          <a:noFill/>
-        </p:spPr>
-        <p:txBody>
-          <a:bodyPr wrap="none" anchor="t" lIns="0" rIns="0" tIns="0" bIns="0">
-            <a:noAutofit/>
-          </a:bodyPr>
-          <a:lstStyle/>
-          <a:p>
-            <a:pPr algn="ctr"/>
-            <a:r>
-              <a:rPr lang="zh-CN" sz="1656" b="0">
-                <a:solidFill>
-                  <a:srgbClr val="3A9B3F"/>
-                </a:solidFill>
-                <a:latin typeface="微软雅黑"/>
-                <a:ea typeface="微软雅黑"/>
-                <a:cs typeface="微软雅黑"/>
-              </a:rPr>
-              <a:t>龙凤采摘园</a:t>
-            </a:r>
-          </a:p>
-        </p:txBody>
-      </p:sp>
-      <p:sp>
-        <p:nvSpPr>
-          <p:cNvPr id="17" name="德惠市区"/>
-          <p:cNvSpPr txBox="1"/>
-          <p:nvPr/>
-        </p:nvSpPr>
-        <p:spPr>
-          <a:xfrm>
-            <a:off x="12004243" y="7024969"/>
-            <a:ext cx="1503273" cy="364845"/>
-          </a:xfrm>
-          <a:prstGeom prst="rect">
-            <a:avLst/>
-          </a:prstGeom>
-          <a:noFill/>
-        </p:spPr>
-        <p:txBody>
-          <a:bodyPr wrap="none" anchor="t" lIns="0" rIns="0" tIns="0" bIns="0">
-            <a:noAutofit/>
-          </a:bodyPr>
-          <a:lstStyle/>
-          <a:p>
-            <a:pPr algn="ctr"/>
-            <a:r>
-              <a:rPr lang="zh-CN" sz="2160" b="1" spc="288">
-                <a:solidFill>
-                  <a:srgbClr val="8A8AA8"/>
-                </a:solidFill>
-                <a:latin typeface="微软雅黑"/>
-                <a:ea typeface="微软雅黑"/>
-                <a:cs typeface="微软雅黑"/>
-              </a:rPr>
-              <a:t>德惠市区</a:t>
-            </a:r>
-          </a:p>
-        </p:txBody>
-      </p:sp>
-      <p:sp>
-        <p:nvSpPr>
-          <p:cNvPr id="18" name="红旗大市场"/>
-          <p:cNvSpPr txBox="1"/>
-          <p:nvPr/>
-        </p:nvSpPr>
-        <p:spPr>
-          <a:xfrm>
-            <a:off x="12216384" y="7577852"/>
+            <a:off x="12755880" y="7870460"/>
             <a:ext cx="1229868" cy="267553"/>
           </a:xfrm>
           <a:prstGeom prst="rect">
@@ -3814,14 +3747,14 @@
       </p:sp>
       <p:sp>
         <p:nvSpPr>
-          <p:cNvPr id="19" name="中林石油加油站"/>
+          <p:cNvPr id="17" name="龙凤采摘园"/>
           <p:cNvSpPr txBox="1"/>
           <p:nvPr/>
         </p:nvSpPr>
         <p:spPr>
           <a:xfrm>
-            <a:off x="12847320" y="5840492"/>
-            <a:ext cx="1692554" cy="267553"/>
+            <a:off x="11887200" y="8638556"/>
+            <a:ext cx="1229868" cy="267553"/>
           </a:xfrm>
           <a:prstGeom prst="rect">
             <a:avLst/>
@@ -3838,7 +3771,51 @@
             <a:r>
               <a:rPr lang="zh-CN" sz="1584" b="0">
                 <a:solidFill>
-                  <a:srgbClr val="2F7BF6"/>
+                  <a:srgbClr val="3A9B3F"/>
+                </a:solidFill>
+                <a:effectLst>
+                  <a:glow rad="27432">
+                    <a:srgbClr val="FFF3F7">
+                      <a:alpha val="90000"/>
+                    </a:srgbClr>
+                  </a:glow>
+                </a:effectLst>
+                <a:latin typeface="微软雅黑"/>
+                <a:ea typeface="微软雅黑"/>
+                <a:cs typeface="微软雅黑"/>
+              </a:rPr>
+              <a:t>龙凤采摘园</a:t>
+            </a:r>
+          </a:p>
+        </p:txBody>
+      </p:sp>
+      <p:sp>
+        <p:nvSpPr>
+          <p:cNvPr id="18" name="中林石油加油站"/>
+          <p:cNvSpPr txBox="1"/>
+          <p:nvPr/>
+        </p:nvSpPr>
+        <p:spPr>
+          <a:xfrm>
+            <a:off x="12847320" y="6096524"/>
+            <a:ext cx="1692554" cy="267553"/>
+          </a:xfrm>
+          <a:prstGeom prst="rect">
+            <a:avLst/>
+          </a:prstGeom>
+          <a:noFill/>
+        </p:spPr>
+        <p:txBody>
+          <a:bodyPr wrap="none" anchor="t" lIns="0" rIns="0" tIns="0" bIns="0">
+            <a:noAutofit/>
+          </a:bodyPr>
+          <a:lstStyle/>
+          <a:p>
+            <a:pPr algn="l"/>
+            <a:r>
+              <a:rPr lang="zh-CN" sz="1584" b="0">
+                <a:solidFill>
+                  <a:srgbClr val="2F6FD6"/>
                 </a:solidFill>
                 <a:effectLst>
                   <a:glow rad="27432">
@@ -3858,13 +3835,13 @@
       </p:sp>
       <p:sp>
         <p:nvSpPr>
-          <p:cNvPr id="20" name="王三姐绿色生态园"/>
+          <p:cNvPr id="19" name="王三姐绿色生态园"/>
           <p:cNvSpPr txBox="1"/>
           <p:nvPr/>
         </p:nvSpPr>
         <p:spPr>
           <a:xfrm>
-            <a:off x="14484096" y="6334268"/>
+            <a:off x="14447520" y="6626876"/>
             <a:ext cx="1923897" cy="267553"/>
           </a:xfrm>
           <a:prstGeom prst="rect">
@@ -3902,13 +3879,13 @@
       </p:sp>
       <p:sp>
         <p:nvSpPr>
-          <p:cNvPr id="21" name="新郎家"/>
+          <p:cNvPr id="20" name="新郎家"/>
           <p:cNvSpPr txBox="1"/>
           <p:nvPr/>
         </p:nvSpPr>
         <p:spPr>
           <a:xfrm>
-            <a:off x="2286000" y="1788924"/>
+            <a:off x="2286000" y="1697484"/>
             <a:ext cx="1574779" cy="578888"/>
           </a:xfrm>
           <a:prstGeom prst="rect">
@@ -3946,13 +3923,13 @@
       </p:sp>
       <p:sp>
         <p:nvSpPr>
-          <p:cNvPr id="22" name="中国石油万金塔派出所北加油站"/>
+          <p:cNvPr id="21" name="中国石油万金塔派出所北加油站"/>
           <p:cNvSpPr txBox="1"/>
           <p:nvPr/>
         </p:nvSpPr>
         <p:spPr>
           <a:xfrm>
-            <a:off x="2304288" y="2401287"/>
+            <a:off x="2304288" y="2309847"/>
             <a:ext cx="3606393" cy="291876"/>
           </a:xfrm>
           <a:prstGeom prst="rect">
@@ -3990,14 +3967,14 @@
       </p:sp>
       <p:sp>
         <p:nvSpPr>
-          <p:cNvPr id="23" name="新娘家"/>
+          <p:cNvPr id="22" name="新娘家"/>
           <p:cNvSpPr txBox="1"/>
           <p:nvPr/>
         </p:nvSpPr>
         <p:spPr>
           <a:xfrm>
-            <a:off x="11082528" y="10861614"/>
-            <a:ext cx="1628409" cy="599562"/>
+            <a:off x="11430000" y="11183432"/>
+            <a:ext cx="1413891" cy="516864"/>
           </a:xfrm>
           <a:prstGeom prst="rect">
             <a:avLst/>
@@ -4012,12 +3989,12 @@
           <a:p>
             <a:pPr algn="l"/>
             <a:r>
-              <a:rPr lang="zh-CN" sz="3550" b="1">
+              <a:rPr lang="zh-CN" sz="3060" b="1">
                 <a:solidFill>
                   <a:srgbClr val="E8202C"/>
                 </a:solidFill>
                 <a:effectLst>
-                  <a:glow rad="45079">
+                  <a:glow rad="38862">
                     <a:srgbClr val="FFFFFF">
                       <a:alpha val="90000"/>
                     </a:srgbClr>
@@ -4034,14 +4011,14 @@
       </p:sp>
       <p:sp>
         <p:nvSpPr>
-          <p:cNvPr id="24" name="腰周家"/>
+          <p:cNvPr id="23" name="腰周家"/>
           <p:cNvSpPr txBox="1"/>
           <p:nvPr/>
         </p:nvSpPr>
         <p:spPr>
           <a:xfrm>
-            <a:off x="12545568" y="11010692"/>
-            <a:ext cx="1082649" cy="389168"/>
+            <a:off x="12691872" y="11305422"/>
+            <a:ext cx="956462" cy="340522"/>
           </a:xfrm>
           <a:prstGeom prst="rect">
             <a:avLst/>
@@ -4056,12 +4033,12 @@
           <a:p>
             <a:pPr algn="l"/>
             <a:r>
-              <a:rPr lang="zh-CN" sz="2304" b="1">
+              <a:rPr lang="zh-CN" sz="2016" b="1">
                 <a:solidFill>
                   <a:srgbClr val="C2185B"/>
                 </a:solidFill>
                 <a:effectLst>
-                  <a:glow rad="29260">
+                  <a:glow rad="27432">
                     <a:srgbClr val="FFF3F7">
                       <a:alpha val="90000"/>
                     </a:srgbClr>
@@ -4078,14 +4055,14 @@
       </p:sp>
       <p:sp>
         <p:nvSpPr>
-          <p:cNvPr id="25" name="德惠市人民政府"/>
+          <p:cNvPr id="24" name="德惠市"/>
           <p:cNvSpPr txBox="1"/>
           <p:nvPr/>
         </p:nvSpPr>
         <p:spPr>
           <a:xfrm>
-            <a:off x="13936827" y="8924800"/>
-            <a:ext cx="2575864" cy="413491"/>
+            <a:off x="14196974" y="7649943"/>
+            <a:ext cx="830275" cy="291876"/>
           </a:xfrm>
           <a:prstGeom prst="rect">
             <a:avLst/>
@@ -4100,12 +4077,12 @@
           <a:p>
             <a:pPr algn="ctr"/>
             <a:r>
-              <a:rPr lang="zh-CN" sz="2448" b="1">
+              <a:rPr lang="zh-CN" sz="1728" b="1">
                 <a:solidFill>
                   <a:srgbClr val="D35400"/>
                 </a:solidFill>
                 <a:effectLst>
-                  <a:glow rad="31089">
+                  <a:glow rad="27432">
                     <a:srgbClr val="FFFFFF">
                       <a:alpha val="90000"/>
                     </a:srgbClr>
@@ -4115,7 +4092,51 @@
                 <a:ea typeface="微软雅黑"/>
                 <a:cs typeface="微软雅黑"/>
               </a:rPr>
-              <a:t>德惠市人民政府</a:t>
+              <a:t>德惠市</a:t>
+            </a:r>
+          </a:p>
+        </p:txBody>
+      </p:sp>
+      <p:sp>
+        <p:nvSpPr>
+          <p:cNvPr id="25" name="人民政府"/>
+          <p:cNvSpPr txBox="1"/>
+          <p:nvPr/>
+        </p:nvSpPr>
+        <p:spPr>
+          <a:xfrm>
+            <a:off x="14070787" y="7924263"/>
+            <a:ext cx="1082649" cy="291876"/>
+          </a:xfrm>
+          <a:prstGeom prst="rect">
+            <a:avLst/>
+          </a:prstGeom>
+          <a:noFill/>
+        </p:spPr>
+        <p:txBody>
+          <a:bodyPr wrap="none" anchor="t" lIns="0" rIns="0" tIns="0" bIns="0">
+            <a:noAutofit/>
+          </a:bodyPr>
+          <a:lstStyle/>
+          <a:p>
+            <a:pPr algn="ctr"/>
+            <a:r>
+              <a:rPr lang="zh-CN" sz="1728" b="1">
+                <a:solidFill>
+                  <a:srgbClr val="D35400"/>
+                </a:solidFill>
+                <a:effectLst>
+                  <a:glow rad="27432">
+                    <a:srgbClr val="FFFFFF">
+                      <a:alpha val="90000"/>
+                    </a:srgbClr>
+                  </a:glow>
+                </a:effectLst>
+                <a:latin typeface="微软雅黑"/>
+                <a:ea typeface="微软雅黑"/>
+                <a:cs typeface="微软雅黑"/>
+              </a:rPr>
+              <a:t>人民政府</a:t>
             </a:r>
           </a:p>
         </p:txBody>
@@ -4209,8 +4230,8 @@
         </p:nvSpPr>
         <p:spPr>
           <a:xfrm>
-            <a:off x="14541703" y="364955"/>
-            <a:ext cx="451713" cy="437814"/>
+            <a:off x="14562734" y="147620"/>
+            <a:ext cx="409651" cy="389168"/>
           </a:xfrm>
           <a:prstGeom prst="rect">
             <a:avLst/>
@@ -4225,7 +4246,7 @@
           <a:p>
             <a:pPr algn="ctr"/>
             <a:r>
-              <a:rPr lang="zh-CN" sz="2592" b="1">
+              <a:rPr lang="zh-CN" sz="2304" b="1">
                 <a:solidFill>
                   <a:srgbClr val="333333"/>
                 </a:solidFill>
@@ -4246,8 +4267,8 @@
         </p:nvSpPr>
         <p:spPr>
           <a:xfrm>
-            <a:off x="14165610" y="2066800"/>
-            <a:ext cx="1002731" cy="413491"/>
+            <a:off x="14192951" y="1628948"/>
+            <a:ext cx="948049" cy="389168"/>
           </a:xfrm>
           <a:prstGeom prst="rect">
             <a:avLst/>
@@ -4262,7 +4283,7 @@
           <a:p>
             <a:pPr algn="ctr"/>
             <a:r>
-              <a:rPr lang="zh-CN" sz="2448" b="1">
+              <a:rPr lang="zh-CN" sz="2304" b="1">
                 <a:solidFill>
                   <a:srgbClr val="333333"/>
                 </a:solidFill>
@@ -4283,7 +4304,7 @@
         </p:nvSpPr>
         <p:spPr>
           <a:xfrm>
-            <a:off x="14100048" y="2821381"/>
+            <a:off x="14100048" y="2345893"/>
             <a:ext cx="1124711" cy="304038"/>
           </a:xfrm>
           <a:prstGeom prst="rect">
@@ -4320,7 +4341,7 @@
         </p:nvSpPr>
         <p:spPr>
           <a:xfrm>
-            <a:off x="14100048" y="3333445"/>
+            <a:off x="14100048" y="2857957"/>
             <a:ext cx="2176271" cy="304038"/>
           </a:xfrm>
           <a:prstGeom prst="rect">
@@ -4357,7 +4378,7 @@
         </p:nvSpPr>
         <p:spPr>
           <a:xfrm>
-            <a:off x="14100048" y="3845509"/>
+            <a:off x="14100048" y="3370021"/>
             <a:ext cx="1124711" cy="304038"/>
           </a:xfrm>
           <a:prstGeom prst="rect">

</xml_diff>